<commit_message>
test button and GUI mode
</commit_message>
<xml_diff>
--- a/sunriseRobot/app_SunriseRobot/info/GPIO_pin_connections.pptx
+++ b/sunriseRobot/app_SunriseRobot/info/GPIO_pin_connections.pptx
@@ -4,6 +4,9 @@
   <p:sldMasterIdLst>
     <p:sldMasterId id="2147483648" r:id="rId1"/>
   </p:sldMasterIdLst>
+  <p:notesMasterIdLst>
+    <p:notesMasterId r:id="rId3"/>
+  </p:notesMasterIdLst>
   <p:sldIdLst>
     <p:sldId id="256" r:id="rId2"/>
   </p:sldIdLst>
@@ -112,6 +115,439 @@
 </p:presentation>
 </file>
 
+<file path=ppt/notesMasters/notesMaster1.xml><?xml version="1.0" encoding="utf-8"?>
+<p:notesMaster xmlns:a="http://schemas.openxmlformats.org/drawingml/2006/main" xmlns:r="http://schemas.openxmlformats.org/officeDocument/2006/relationships" xmlns:p="http://schemas.openxmlformats.org/presentationml/2006/main">
+  <p:cSld>
+    <p:bg>
+      <p:bgRef idx="1001">
+        <a:schemeClr val="bg1"/>
+      </p:bgRef>
+    </p:bg>
+    <p:spTree>
+      <p:nvGrpSpPr>
+        <p:cNvPr id="1" name=""/>
+        <p:cNvGrpSpPr/>
+        <p:nvPr/>
+      </p:nvGrpSpPr>
+      <p:grpSpPr>
+        <a:xfrm>
+          <a:off x="0" y="0"/>
+          <a:ext cx="0" cy="0"/>
+          <a:chOff x="0" y="0"/>
+          <a:chExt cx="0" cy="0"/>
+        </a:xfrm>
+      </p:grpSpPr>
+      <p:sp>
+        <p:nvSpPr>
+          <p:cNvPr id="2" name="Header Placeholder 1"/>
+          <p:cNvSpPr>
+            <a:spLocks noGrp="1"/>
+          </p:cNvSpPr>
+          <p:nvPr>
+            <p:ph type="hdr" sz="quarter"/>
+          </p:nvPr>
+        </p:nvSpPr>
+        <p:spPr>
+          <a:xfrm>
+            <a:off x="0" y="0"/>
+            <a:ext cx="2971800" cy="458788"/>
+          </a:xfrm>
+          <a:prstGeom prst="rect">
+            <a:avLst/>
+          </a:prstGeom>
+        </p:spPr>
+        <p:txBody>
+          <a:bodyPr vert="horz" lIns="91440" tIns="45720" rIns="91440" bIns="45720" rtlCol="0"/>
+          <a:lstStyle>
+            <a:lvl1pPr algn="l">
+              <a:defRPr sz="1200"/>
+            </a:lvl1pPr>
+          </a:lstStyle>
+          <a:p>
+            <a:endParaRPr lang="en-US"/>
+          </a:p>
+        </p:txBody>
+      </p:sp>
+      <p:sp>
+        <p:nvSpPr>
+          <p:cNvPr id="3" name="Date Placeholder 2"/>
+          <p:cNvSpPr>
+            <a:spLocks noGrp="1"/>
+          </p:cNvSpPr>
+          <p:nvPr>
+            <p:ph type="dt" idx="1"/>
+          </p:nvPr>
+        </p:nvSpPr>
+        <p:spPr>
+          <a:xfrm>
+            <a:off x="3884613" y="0"/>
+            <a:ext cx="2971800" cy="458788"/>
+          </a:xfrm>
+          <a:prstGeom prst="rect">
+            <a:avLst/>
+          </a:prstGeom>
+        </p:spPr>
+        <p:txBody>
+          <a:bodyPr vert="horz" lIns="91440" tIns="45720" rIns="91440" bIns="45720" rtlCol="0"/>
+          <a:lstStyle>
+            <a:lvl1pPr algn="r">
+              <a:defRPr sz="1200"/>
+            </a:lvl1pPr>
+          </a:lstStyle>
+          <a:p>
+            <a:fld id="{2FDF1BED-853F-4245-91EE-FADE81ADF85A}" type="datetimeFigureOut">
+              <a:rPr lang="en-US" smtClean="0"/>
+              <a:t>5/31/2025</a:t>
+            </a:fld>
+            <a:endParaRPr lang="en-US"/>
+          </a:p>
+        </p:txBody>
+      </p:sp>
+      <p:sp>
+        <p:nvSpPr>
+          <p:cNvPr id="4" name="Slide Image Placeholder 3"/>
+          <p:cNvSpPr>
+            <a:spLocks noGrp="1" noRot="1" noChangeAspect="1"/>
+          </p:cNvSpPr>
+          <p:nvPr>
+            <p:ph type="sldImg" idx="2"/>
+          </p:nvPr>
+        </p:nvSpPr>
+        <p:spPr>
+          <a:xfrm>
+            <a:off x="685800" y="1143000"/>
+            <a:ext cx="5486400" cy="3086100"/>
+          </a:xfrm>
+          <a:prstGeom prst="rect">
+            <a:avLst/>
+          </a:prstGeom>
+          <a:noFill/>
+          <a:ln w="12700">
+            <a:solidFill>
+              <a:prstClr val="black"/>
+            </a:solidFill>
+          </a:ln>
+        </p:spPr>
+        <p:txBody>
+          <a:bodyPr vert="horz" lIns="91440" tIns="45720" rIns="91440" bIns="45720" rtlCol="0" anchor="ctr"/>
+          <a:lstStyle/>
+          <a:p>
+            <a:endParaRPr lang="en-US"/>
+          </a:p>
+        </p:txBody>
+      </p:sp>
+      <p:sp>
+        <p:nvSpPr>
+          <p:cNvPr id="5" name="Notes Placeholder 4"/>
+          <p:cNvSpPr>
+            <a:spLocks noGrp="1"/>
+          </p:cNvSpPr>
+          <p:nvPr>
+            <p:ph type="body" sz="quarter" idx="3"/>
+          </p:nvPr>
+        </p:nvSpPr>
+        <p:spPr>
+          <a:xfrm>
+            <a:off x="685800" y="4400550"/>
+            <a:ext cx="5486400" cy="3600450"/>
+          </a:xfrm>
+          <a:prstGeom prst="rect">
+            <a:avLst/>
+          </a:prstGeom>
+        </p:spPr>
+        <p:txBody>
+          <a:bodyPr vert="horz" lIns="91440" tIns="45720" rIns="91440" bIns="45720" rtlCol="0"/>
+          <a:lstStyle/>
+          <a:p>
+            <a:pPr lvl="0"/>
+            <a:r>
+              <a:rPr lang="en-US"/>
+              <a:t>Click to edit Master text styles</a:t>
+            </a:r>
+          </a:p>
+          <a:p>
+            <a:pPr lvl="1"/>
+            <a:r>
+              <a:rPr lang="en-US"/>
+              <a:t>Second level</a:t>
+            </a:r>
+          </a:p>
+          <a:p>
+            <a:pPr lvl="2"/>
+            <a:r>
+              <a:rPr lang="en-US"/>
+              <a:t>Third level</a:t>
+            </a:r>
+          </a:p>
+          <a:p>
+            <a:pPr lvl="3"/>
+            <a:r>
+              <a:rPr lang="en-US"/>
+              <a:t>Fourth level</a:t>
+            </a:r>
+          </a:p>
+          <a:p>
+            <a:pPr lvl="4"/>
+            <a:r>
+              <a:rPr lang="en-US"/>
+              <a:t>Fifth level</a:t>
+            </a:r>
+          </a:p>
+        </p:txBody>
+      </p:sp>
+      <p:sp>
+        <p:nvSpPr>
+          <p:cNvPr id="6" name="Footer Placeholder 5"/>
+          <p:cNvSpPr>
+            <a:spLocks noGrp="1"/>
+          </p:cNvSpPr>
+          <p:nvPr>
+            <p:ph type="ftr" sz="quarter" idx="4"/>
+          </p:nvPr>
+        </p:nvSpPr>
+        <p:spPr>
+          <a:xfrm>
+            <a:off x="0" y="8685213"/>
+            <a:ext cx="2971800" cy="458787"/>
+          </a:xfrm>
+          <a:prstGeom prst="rect">
+            <a:avLst/>
+          </a:prstGeom>
+        </p:spPr>
+        <p:txBody>
+          <a:bodyPr vert="horz" lIns="91440" tIns="45720" rIns="91440" bIns="45720" rtlCol="0" anchor="b"/>
+          <a:lstStyle>
+            <a:lvl1pPr algn="l">
+              <a:defRPr sz="1200"/>
+            </a:lvl1pPr>
+          </a:lstStyle>
+          <a:p>
+            <a:endParaRPr lang="en-US"/>
+          </a:p>
+        </p:txBody>
+      </p:sp>
+      <p:sp>
+        <p:nvSpPr>
+          <p:cNvPr id="7" name="Slide Number Placeholder 6"/>
+          <p:cNvSpPr>
+            <a:spLocks noGrp="1"/>
+          </p:cNvSpPr>
+          <p:nvPr>
+            <p:ph type="sldNum" sz="quarter" idx="5"/>
+          </p:nvPr>
+        </p:nvSpPr>
+        <p:spPr>
+          <a:xfrm>
+            <a:off x="3884613" y="8685213"/>
+            <a:ext cx="2971800" cy="458787"/>
+          </a:xfrm>
+          <a:prstGeom prst="rect">
+            <a:avLst/>
+          </a:prstGeom>
+        </p:spPr>
+        <p:txBody>
+          <a:bodyPr vert="horz" lIns="91440" tIns="45720" rIns="91440" bIns="45720" rtlCol="0" anchor="b"/>
+          <a:lstStyle>
+            <a:lvl1pPr algn="r">
+              <a:defRPr sz="1200"/>
+            </a:lvl1pPr>
+          </a:lstStyle>
+          <a:p>
+            <a:fld id="{50435334-9C50-48C8-9B05-2910907B1BD7}" type="slidenum">
+              <a:rPr lang="en-US" smtClean="0"/>
+              <a:t>‹#›</a:t>
+            </a:fld>
+            <a:endParaRPr lang="en-US"/>
+          </a:p>
+        </p:txBody>
+      </p:sp>
+    </p:spTree>
+    <p:extLst>
+      <p:ext uri="{BB962C8B-B14F-4D97-AF65-F5344CB8AC3E}">
+        <p14:creationId xmlns:p14="http://schemas.microsoft.com/office/powerpoint/2010/main" val="3878831518"/>
+      </p:ext>
+    </p:extLst>
+  </p:cSld>
+  <p:clrMap bg1="lt1" tx1="dk1" bg2="lt2" tx2="dk2" accent1="accent1" accent2="accent2" accent3="accent3" accent4="accent4" accent5="accent5" accent6="accent6" hlink="hlink" folHlink="folHlink"/>
+  <p:notesStyle>
+    <a:lvl1pPr marL="0" algn="l" defTabSz="914400" rtl="0" eaLnBrk="1" latinLnBrk="0" hangingPunct="1">
+      <a:defRPr sz="1200" kern="1200">
+        <a:solidFill>
+          <a:schemeClr val="tx1"/>
+        </a:solidFill>
+        <a:latin typeface="+mn-lt"/>
+        <a:ea typeface="+mn-ea"/>
+        <a:cs typeface="+mn-cs"/>
+      </a:defRPr>
+    </a:lvl1pPr>
+    <a:lvl2pPr marL="457200" algn="l" defTabSz="914400" rtl="0" eaLnBrk="1" latinLnBrk="0" hangingPunct="1">
+      <a:defRPr sz="1200" kern="1200">
+        <a:solidFill>
+          <a:schemeClr val="tx1"/>
+        </a:solidFill>
+        <a:latin typeface="+mn-lt"/>
+        <a:ea typeface="+mn-ea"/>
+        <a:cs typeface="+mn-cs"/>
+      </a:defRPr>
+    </a:lvl2pPr>
+    <a:lvl3pPr marL="914400" algn="l" defTabSz="914400" rtl="0" eaLnBrk="1" latinLnBrk="0" hangingPunct="1">
+      <a:defRPr sz="1200" kern="1200">
+        <a:solidFill>
+          <a:schemeClr val="tx1"/>
+        </a:solidFill>
+        <a:latin typeface="+mn-lt"/>
+        <a:ea typeface="+mn-ea"/>
+        <a:cs typeface="+mn-cs"/>
+      </a:defRPr>
+    </a:lvl3pPr>
+    <a:lvl4pPr marL="1371600" algn="l" defTabSz="914400" rtl="0" eaLnBrk="1" latinLnBrk="0" hangingPunct="1">
+      <a:defRPr sz="1200" kern="1200">
+        <a:solidFill>
+          <a:schemeClr val="tx1"/>
+        </a:solidFill>
+        <a:latin typeface="+mn-lt"/>
+        <a:ea typeface="+mn-ea"/>
+        <a:cs typeface="+mn-cs"/>
+      </a:defRPr>
+    </a:lvl4pPr>
+    <a:lvl5pPr marL="1828800" algn="l" defTabSz="914400" rtl="0" eaLnBrk="1" latinLnBrk="0" hangingPunct="1">
+      <a:defRPr sz="1200" kern="1200">
+        <a:solidFill>
+          <a:schemeClr val="tx1"/>
+        </a:solidFill>
+        <a:latin typeface="+mn-lt"/>
+        <a:ea typeface="+mn-ea"/>
+        <a:cs typeface="+mn-cs"/>
+      </a:defRPr>
+    </a:lvl5pPr>
+    <a:lvl6pPr marL="2286000" algn="l" defTabSz="914400" rtl="0" eaLnBrk="1" latinLnBrk="0" hangingPunct="1">
+      <a:defRPr sz="1200" kern="1200">
+        <a:solidFill>
+          <a:schemeClr val="tx1"/>
+        </a:solidFill>
+        <a:latin typeface="+mn-lt"/>
+        <a:ea typeface="+mn-ea"/>
+        <a:cs typeface="+mn-cs"/>
+      </a:defRPr>
+    </a:lvl6pPr>
+    <a:lvl7pPr marL="2743200" algn="l" defTabSz="914400" rtl="0" eaLnBrk="1" latinLnBrk="0" hangingPunct="1">
+      <a:defRPr sz="1200" kern="1200">
+        <a:solidFill>
+          <a:schemeClr val="tx1"/>
+        </a:solidFill>
+        <a:latin typeface="+mn-lt"/>
+        <a:ea typeface="+mn-ea"/>
+        <a:cs typeface="+mn-cs"/>
+      </a:defRPr>
+    </a:lvl7pPr>
+    <a:lvl8pPr marL="3200400" algn="l" defTabSz="914400" rtl="0" eaLnBrk="1" latinLnBrk="0" hangingPunct="1">
+      <a:defRPr sz="1200" kern="1200">
+        <a:solidFill>
+          <a:schemeClr val="tx1"/>
+        </a:solidFill>
+        <a:latin typeface="+mn-lt"/>
+        <a:ea typeface="+mn-ea"/>
+        <a:cs typeface="+mn-cs"/>
+      </a:defRPr>
+    </a:lvl8pPr>
+    <a:lvl9pPr marL="3657600" algn="l" defTabSz="914400" rtl="0" eaLnBrk="1" latinLnBrk="0" hangingPunct="1">
+      <a:defRPr sz="1200" kern="1200">
+        <a:solidFill>
+          <a:schemeClr val="tx1"/>
+        </a:solidFill>
+        <a:latin typeface="+mn-lt"/>
+        <a:ea typeface="+mn-ea"/>
+        <a:cs typeface="+mn-cs"/>
+      </a:defRPr>
+    </a:lvl9pPr>
+  </p:notesStyle>
+</p:notesMaster>
+</file>
+
+<file path=ppt/notesSlides/notesSlide1.xml><?xml version="1.0" encoding="utf-8"?>
+<p:notes xmlns:a="http://schemas.openxmlformats.org/drawingml/2006/main" xmlns:r="http://schemas.openxmlformats.org/officeDocument/2006/relationships" xmlns:p="http://schemas.openxmlformats.org/presentationml/2006/main">
+  <p:cSld>
+    <p:spTree>
+      <p:nvGrpSpPr>
+        <p:cNvPr id="1" name=""/>
+        <p:cNvGrpSpPr/>
+        <p:nvPr/>
+      </p:nvGrpSpPr>
+      <p:grpSpPr>
+        <a:xfrm>
+          <a:off x="0" y="0"/>
+          <a:ext cx="0" cy="0"/>
+          <a:chOff x="0" y="0"/>
+          <a:chExt cx="0" cy="0"/>
+        </a:xfrm>
+      </p:grpSpPr>
+      <p:sp>
+        <p:nvSpPr>
+          <p:cNvPr id="2" name="Slide Image Placeholder 1"/>
+          <p:cNvSpPr>
+            <a:spLocks noGrp="1" noRot="1" noChangeAspect="1"/>
+          </p:cNvSpPr>
+          <p:nvPr>
+            <p:ph type="sldImg"/>
+          </p:nvPr>
+        </p:nvSpPr>
+        <p:spPr/>
+      </p:sp>
+      <p:sp>
+        <p:nvSpPr>
+          <p:cNvPr id="3" name="Notes Placeholder 2"/>
+          <p:cNvSpPr>
+            <a:spLocks noGrp="1"/>
+          </p:cNvSpPr>
+          <p:nvPr>
+            <p:ph type="body" idx="1"/>
+          </p:nvPr>
+        </p:nvSpPr>
+        <p:spPr/>
+        <p:txBody>
+          <a:bodyPr/>
+          <a:lstStyle/>
+          <a:p>
+            <a:endParaRPr lang="en-US" dirty="0"/>
+          </a:p>
+        </p:txBody>
+      </p:sp>
+      <p:sp>
+        <p:nvSpPr>
+          <p:cNvPr id="4" name="Slide Number Placeholder 3"/>
+          <p:cNvSpPr>
+            <a:spLocks noGrp="1"/>
+          </p:cNvSpPr>
+          <p:nvPr>
+            <p:ph type="sldNum" sz="quarter" idx="5"/>
+          </p:nvPr>
+        </p:nvSpPr>
+        <p:spPr/>
+        <p:txBody>
+          <a:bodyPr/>
+          <a:lstStyle/>
+          <a:p>
+            <a:fld id="{50435334-9C50-48C8-9B05-2910907B1BD7}" type="slidenum">
+              <a:rPr lang="en-US" smtClean="0"/>
+              <a:t>1</a:t>
+            </a:fld>
+            <a:endParaRPr lang="en-US"/>
+          </a:p>
+        </p:txBody>
+      </p:sp>
+    </p:spTree>
+    <p:extLst>
+      <p:ext uri="{BB962C8B-B14F-4D97-AF65-F5344CB8AC3E}">
+        <p14:creationId xmlns:p14="http://schemas.microsoft.com/office/powerpoint/2010/main" val="3458729164"/>
+      </p:ext>
+    </p:extLst>
+  </p:cSld>
+  <p:clrMapOvr>
+    <a:masterClrMapping/>
+  </p:clrMapOvr>
+</p:notes>
+</file>
+
 <file path=ppt/slideLayouts/slideLayout1.xml><?xml version="1.0" encoding="utf-8"?>
 <p:sldLayout xmlns:a="http://schemas.openxmlformats.org/drawingml/2006/main" xmlns:r="http://schemas.openxmlformats.org/officeDocument/2006/relationships" xmlns:p="http://schemas.openxmlformats.org/presentationml/2006/main" type="title" preserve="1">
   <p:cSld name="Title Slide">
@@ -259,7 +695,7 @@
           <a:p>
             <a:fld id="{640B36D2-B36D-4CD7-B01F-B18C9CC58E4D}" type="datetimeFigureOut">
               <a:rPr lang="en-US" smtClean="0"/>
-              <a:t>5/29/2025</a:t>
+              <a:t>5/31/2025</a:t>
             </a:fld>
             <a:endParaRPr lang="en-US"/>
           </a:p>
@@ -457,7 +893,7 @@
           <a:p>
             <a:fld id="{640B36D2-B36D-4CD7-B01F-B18C9CC58E4D}" type="datetimeFigureOut">
               <a:rPr lang="en-US" smtClean="0"/>
-              <a:t>5/29/2025</a:t>
+              <a:t>5/31/2025</a:t>
             </a:fld>
             <a:endParaRPr lang="en-US"/>
           </a:p>
@@ -665,7 +1101,7 @@
           <a:p>
             <a:fld id="{640B36D2-B36D-4CD7-B01F-B18C9CC58E4D}" type="datetimeFigureOut">
               <a:rPr lang="en-US" smtClean="0"/>
-              <a:t>5/29/2025</a:t>
+              <a:t>5/31/2025</a:t>
             </a:fld>
             <a:endParaRPr lang="en-US"/>
           </a:p>
@@ -863,7 +1299,7 @@
           <a:p>
             <a:fld id="{640B36D2-B36D-4CD7-B01F-B18C9CC58E4D}" type="datetimeFigureOut">
               <a:rPr lang="en-US" smtClean="0"/>
-              <a:t>5/29/2025</a:t>
+              <a:t>5/31/2025</a:t>
             </a:fld>
             <a:endParaRPr lang="en-US"/>
           </a:p>
@@ -1138,7 +1574,7 @@
           <a:p>
             <a:fld id="{640B36D2-B36D-4CD7-B01F-B18C9CC58E4D}" type="datetimeFigureOut">
               <a:rPr lang="en-US" smtClean="0"/>
-              <a:t>5/29/2025</a:t>
+              <a:t>5/31/2025</a:t>
             </a:fld>
             <a:endParaRPr lang="en-US"/>
           </a:p>
@@ -1403,7 +1839,7 @@
           <a:p>
             <a:fld id="{640B36D2-B36D-4CD7-B01F-B18C9CC58E4D}" type="datetimeFigureOut">
               <a:rPr lang="en-US" smtClean="0"/>
-              <a:t>5/29/2025</a:t>
+              <a:t>5/31/2025</a:t>
             </a:fld>
             <a:endParaRPr lang="en-US"/>
           </a:p>
@@ -1815,7 +2251,7 @@
           <a:p>
             <a:fld id="{640B36D2-B36D-4CD7-B01F-B18C9CC58E4D}" type="datetimeFigureOut">
               <a:rPr lang="en-US" smtClean="0"/>
-              <a:t>5/29/2025</a:t>
+              <a:t>5/31/2025</a:t>
             </a:fld>
             <a:endParaRPr lang="en-US"/>
           </a:p>
@@ -1956,7 +2392,7 @@
           <a:p>
             <a:fld id="{640B36D2-B36D-4CD7-B01F-B18C9CC58E4D}" type="datetimeFigureOut">
               <a:rPr lang="en-US" smtClean="0"/>
-              <a:t>5/29/2025</a:t>
+              <a:t>5/31/2025</a:t>
             </a:fld>
             <a:endParaRPr lang="en-US"/>
           </a:p>
@@ -2069,7 +2505,7 @@
           <a:p>
             <a:fld id="{640B36D2-B36D-4CD7-B01F-B18C9CC58E4D}" type="datetimeFigureOut">
               <a:rPr lang="en-US" smtClean="0"/>
-              <a:t>5/29/2025</a:t>
+              <a:t>5/31/2025</a:t>
             </a:fld>
             <a:endParaRPr lang="en-US"/>
           </a:p>
@@ -2380,7 +2816,7 @@
           <a:p>
             <a:fld id="{640B36D2-B36D-4CD7-B01F-B18C9CC58E4D}" type="datetimeFigureOut">
               <a:rPr lang="en-US" smtClean="0"/>
-              <a:t>5/29/2025</a:t>
+              <a:t>5/31/2025</a:t>
             </a:fld>
             <a:endParaRPr lang="en-US"/>
           </a:p>
@@ -2668,7 +3104,7 @@
           <a:p>
             <a:fld id="{640B36D2-B36D-4CD7-B01F-B18C9CC58E4D}" type="datetimeFigureOut">
               <a:rPr lang="en-US" smtClean="0"/>
-              <a:t>5/29/2025</a:t>
+              <a:t>5/31/2025</a:t>
             </a:fld>
             <a:endParaRPr lang="en-US"/>
           </a:p>
@@ -2909,7 +3345,7 @@
           <a:p>
             <a:fld id="{640B36D2-B36D-4CD7-B01F-B18C9CC58E4D}" type="datetimeFigureOut">
               <a:rPr lang="en-US" smtClean="0"/>
-              <a:t>5/29/2025</a:t>
+              <a:t>5/31/2025</a:t>
             </a:fld>
             <a:endParaRPr lang="en-US"/>
           </a:p>
@@ -3341,7 +3777,7 @@
           <p:nvPr/>
         </p:nvPicPr>
         <p:blipFill>
-          <a:blip r:embed="rId2">
+          <a:blip r:embed="rId3">
             <a:extLst>
               <a:ext uri="{28A0092B-C50C-407E-A947-70E740481C1C}">
                 <a14:useLocalDpi xmlns:a14="http://schemas.microsoft.com/office/drawing/2010/main" val="0"/>
@@ -3375,8 +3811,8 @@
         </p:nvSpPr>
         <p:spPr>
           <a:xfrm>
-            <a:off x="2078601" y="597220"/>
-            <a:ext cx="2687074" cy="48111"/>
+            <a:off x="1137604" y="597220"/>
+            <a:ext cx="3628071" cy="45719"/>
           </a:xfrm>
           <a:prstGeom prst="rect">
             <a:avLst/>
@@ -3431,8 +3867,8 @@
         </p:nvCxnSpPr>
         <p:spPr>
           <a:xfrm>
-            <a:off x="2090064" y="928319"/>
-            <a:ext cx="2675611" cy="0"/>
+            <a:off x="1209844" y="936865"/>
+            <a:ext cx="3528000" cy="0"/>
           </a:xfrm>
           <a:prstGeom prst="line">
             <a:avLst/>
@@ -3474,18 +3910,15 @@
         </p:nvCxnSpPr>
         <p:spPr>
           <a:xfrm>
-            <a:off x="2078601" y="1248993"/>
-            <a:ext cx="2687074" cy="0"/>
+            <a:off x="1155657" y="1257539"/>
+            <a:ext cx="3600000" cy="0"/>
           </a:xfrm>
           <a:prstGeom prst="line">
             <a:avLst/>
           </a:prstGeom>
           <a:ln w="57150">
             <a:solidFill>
-              <a:schemeClr val="tx2">
-                <a:lumMod val="75000"/>
-                <a:lumOff val="25000"/>
-              </a:schemeClr>
+              <a:srgbClr val="0070C0"/>
             </a:solidFill>
           </a:ln>
         </p:spPr>
@@ -3520,8 +3953,8 @@
         </p:nvCxnSpPr>
         <p:spPr>
           <a:xfrm>
-            <a:off x="2151136" y="1570876"/>
-            <a:ext cx="2614539" cy="0"/>
+            <a:off x="1100006" y="1579422"/>
+            <a:ext cx="3636000" cy="0"/>
           </a:xfrm>
           <a:prstGeom prst="line">
             <a:avLst/>
@@ -3563,8 +3996,8 @@
         </p:nvCxnSpPr>
         <p:spPr>
           <a:xfrm>
-            <a:off x="2078601" y="1881766"/>
-            <a:ext cx="2687074" cy="0"/>
+            <a:off x="993286" y="1890312"/>
+            <a:ext cx="3744000" cy="0"/>
           </a:xfrm>
           <a:prstGeom prst="line">
             <a:avLst/>
@@ -3606,8 +4039,8 @@
         </p:nvCxnSpPr>
         <p:spPr>
           <a:xfrm>
-            <a:off x="2090064" y="2201491"/>
-            <a:ext cx="2675611" cy="0"/>
+            <a:off x="1047472" y="2210037"/>
+            <a:ext cx="3744000" cy="0"/>
           </a:xfrm>
           <a:prstGeom prst="line">
             <a:avLst/>
@@ -3648,7 +4081,7 @@
           <p:nvPr/>
         </p:nvPicPr>
         <p:blipFill rotWithShape="1">
-          <a:blip r:embed="rId3">
+          <a:blip r:embed="rId4">
             <a:extLst>
               <a:ext uri="{28A0092B-C50C-407E-A947-70E740481C1C}">
                 <a14:useLocalDpi xmlns:a14="http://schemas.microsoft.com/office/drawing/2010/main" val="0"/>
@@ -3659,8 +4092,8 @@
           <a:stretch/>
         </p:blipFill>
         <p:spPr bwMode="auto">
-          <a:xfrm rot="5400000">
-            <a:off x="9172353" y="1176168"/>
+          <a:xfrm rot="16200000">
+            <a:off x="2470885" y="1520507"/>
             <a:ext cx="669128" cy="2636043"/>
           </a:xfrm>
           <a:prstGeom prst="rect">
@@ -3678,60 +4111,6 @@
           </a:extLst>
         </p:spPr>
       </p:pic>
-      <p:sp>
-        <p:nvSpPr>
-          <p:cNvPr id="1037" name="Rectangle 1036">
-            <a:extLst>
-              <a:ext uri="{FF2B5EF4-FFF2-40B4-BE49-F238E27FC236}">
-                <a16:creationId xmlns:a16="http://schemas.microsoft.com/office/drawing/2014/main" id="{6FF4E535-7550-0DC9-2B6C-48BAF2F24329}"/>
-              </a:ext>
-            </a:extLst>
-          </p:cNvPr>
-          <p:cNvSpPr/>
-          <p:nvPr/>
-        </p:nvSpPr>
-        <p:spPr>
-          <a:xfrm>
-            <a:off x="5991225" y="2756852"/>
-            <a:ext cx="2197671" cy="45719"/>
-          </a:xfrm>
-          <a:prstGeom prst="rect">
-            <a:avLst/>
-          </a:prstGeom>
-          <a:solidFill>
-            <a:srgbClr val="04B819"/>
-          </a:solidFill>
-          <a:ln w="3175">
-            <a:solidFill>
-              <a:schemeClr val="tx1"/>
-            </a:solidFill>
-          </a:ln>
-        </p:spPr>
-        <p:style>
-          <a:lnRef idx="2">
-            <a:schemeClr val="accent1">
-              <a:shade val="15000"/>
-            </a:schemeClr>
-          </a:lnRef>
-          <a:fillRef idx="1">
-            <a:schemeClr val="accent1"/>
-          </a:fillRef>
-          <a:effectRef idx="0">
-            <a:schemeClr val="accent1"/>
-          </a:effectRef>
-          <a:fontRef idx="minor">
-            <a:schemeClr val="lt1"/>
-          </a:fontRef>
-        </p:style>
-        <p:txBody>
-          <a:bodyPr rtlCol="0" anchor="ctr"/>
-          <a:lstStyle/>
-          <a:p>
-            <a:pPr algn="ctr"/>
-            <a:endParaRPr lang="en-US"/>
-          </a:p>
-        </p:txBody>
-      </p:sp>
       <p:cxnSp>
         <p:nvCxnSpPr>
           <p:cNvPr id="1038" name="Straight Connector 1037">
@@ -3748,15 +4127,15 @@
         </p:nvCxnSpPr>
         <p:spPr>
           <a:xfrm flipV="1">
-            <a:off x="5991225" y="2201491"/>
-            <a:ext cx="2224088" cy="265359"/>
+            <a:off x="4089945" y="2871312"/>
+            <a:ext cx="701527" cy="242397"/>
           </a:xfrm>
           <a:prstGeom prst="line">
             <a:avLst/>
           </a:prstGeom>
           <a:ln w="57150">
             <a:solidFill>
-              <a:srgbClr val="7030A0"/>
+              <a:srgbClr val="FF0000"/>
             </a:solidFill>
           </a:ln>
         </p:spPr>
@@ -3791,19 +4170,16 @@
           <p:nvPr/>
         </p:nvCxnSpPr>
         <p:spPr>
-          <a:xfrm flipV="1">
-            <a:off x="7358063" y="2494190"/>
-            <a:ext cx="830833" cy="45719"/>
+          <a:xfrm flipH="1">
+            <a:off x="4123471" y="2543040"/>
+            <a:ext cx="2713165" cy="295488"/>
           </a:xfrm>
           <a:prstGeom prst="line">
             <a:avLst/>
           </a:prstGeom>
           <a:ln w="57150">
             <a:solidFill>
-              <a:schemeClr val="tx2">
-                <a:lumMod val="75000"/>
-                <a:lumOff val="25000"/>
-              </a:schemeClr>
+              <a:schemeClr val="tx1"/>
             </a:solidFill>
           </a:ln>
         </p:spPr>
@@ -3837,7 +4213,7 @@
           <p:nvPr/>
         </p:nvPicPr>
         <p:blipFill rotWithShape="1">
-          <a:blip r:embed="rId4">
+          <a:blip r:embed="rId5">
             <a:extLst>
               <a:ext uri="{28A0092B-C50C-407E-A947-70E740481C1C}">
                 <a14:useLocalDpi xmlns:a14="http://schemas.microsoft.com/office/drawing/2010/main" val="0"/>
@@ -3849,7 +4225,7 @@
         </p:blipFill>
         <p:spPr bwMode="auto">
           <a:xfrm rot="5400000">
-            <a:off x="8882125" y="2028923"/>
+            <a:off x="10137322" y="2110976"/>
             <a:ext cx="723553" cy="2636045"/>
           </a:xfrm>
           <a:prstGeom prst="rect">
@@ -3882,11 +4258,11 @@
           <p:nvPr/>
         </p:nvPicPr>
         <p:blipFill rotWithShape="1">
-          <a:blip r:embed="rId5">
+          <a:blip r:embed="rId6">
             <a:extLst>
               <a:ext uri="{BEBA8EAE-BF5A-486C-A8C5-ECC9F3942E4B}">
                 <a14:imgProps xmlns:a14="http://schemas.microsoft.com/office/drawing/2010/main">
-                  <a14:imgLayer r:embed="rId6">
+                  <a14:imgLayer r:embed="rId7">
                     <a14:imgEffect>
                       <a14:sharpenSoften amount="51000"/>
                     </a14:imgEffect>
@@ -3902,8 +4278,8 @@
           <a:stretch/>
         </p:blipFill>
         <p:spPr bwMode="auto">
-          <a:xfrm rot="16200000">
-            <a:off x="2010416" y="2212142"/>
+          <a:xfrm rot="5400000">
+            <a:off x="8814855" y="-156916"/>
             <a:ext cx="1591503" cy="2602432"/>
           </a:xfrm>
           <a:prstGeom prst="rect">
@@ -3921,12 +4297,117 @@
           </a:extLst>
         </p:spPr>
       </p:pic>
+      <p:sp>
+        <p:nvSpPr>
+          <p:cNvPr id="1059" name="TextBox 1058">
+            <a:extLst>
+              <a:ext uri="{FF2B5EF4-FFF2-40B4-BE49-F238E27FC236}">
+                <a16:creationId xmlns:a16="http://schemas.microsoft.com/office/drawing/2014/main" id="{D5DBC9F1-4655-169C-DB16-ECDD80FBC533}"/>
+              </a:ext>
+            </a:extLst>
+          </p:cNvPr>
+          <p:cNvSpPr txBox="1"/>
+          <p:nvPr/>
+        </p:nvSpPr>
+        <p:spPr>
+          <a:xfrm>
+            <a:off x="1510546" y="3134513"/>
+            <a:ext cx="1348446" cy="461665"/>
+          </a:xfrm>
+          <a:prstGeom prst="rect">
+            <a:avLst/>
+          </a:prstGeom>
+          <a:noFill/>
+        </p:spPr>
+        <p:txBody>
+          <a:bodyPr wrap="none" rtlCol="0">
+            <a:spAutoFit/>
+          </a:bodyPr>
+          <a:lstStyle/>
+          <a:p>
+            <a:r>
+              <a:rPr lang="en-US" sz="2400" dirty="0"/>
+              <a:t>3-pin led</a:t>
+            </a:r>
+          </a:p>
+        </p:txBody>
+      </p:sp>
+      <p:sp>
+        <p:nvSpPr>
+          <p:cNvPr id="1060" name="TextBox 1059">
+            <a:extLst>
+              <a:ext uri="{FF2B5EF4-FFF2-40B4-BE49-F238E27FC236}">
+                <a16:creationId xmlns:a16="http://schemas.microsoft.com/office/drawing/2014/main" id="{B009025B-9DFD-57A8-5307-5FA5436F549B}"/>
+              </a:ext>
+            </a:extLst>
+          </p:cNvPr>
+          <p:cNvSpPr txBox="1"/>
+          <p:nvPr/>
+        </p:nvSpPr>
+        <p:spPr>
+          <a:xfrm>
+            <a:off x="10125085" y="3790775"/>
+            <a:ext cx="1348446" cy="461665"/>
+          </a:xfrm>
+          <a:prstGeom prst="rect">
+            <a:avLst/>
+          </a:prstGeom>
+          <a:noFill/>
+        </p:spPr>
+        <p:txBody>
+          <a:bodyPr wrap="none" rtlCol="0">
+            <a:spAutoFit/>
+          </a:bodyPr>
+          <a:lstStyle/>
+          <a:p>
+            <a:r>
+              <a:rPr lang="en-US" sz="2400" dirty="0"/>
+              <a:t>2-pin led</a:t>
+            </a:r>
+          </a:p>
+        </p:txBody>
+      </p:sp>
+      <p:sp>
+        <p:nvSpPr>
+          <p:cNvPr id="1061" name="TextBox 1060">
+            <a:extLst>
+              <a:ext uri="{FF2B5EF4-FFF2-40B4-BE49-F238E27FC236}">
+                <a16:creationId xmlns:a16="http://schemas.microsoft.com/office/drawing/2014/main" id="{133EEB25-6D34-CAD5-E073-6DE3E4FDA44A}"/>
+              </a:ext>
+            </a:extLst>
+          </p:cNvPr>
+          <p:cNvSpPr txBox="1"/>
+          <p:nvPr/>
+        </p:nvSpPr>
+        <p:spPr>
+          <a:xfrm>
+            <a:off x="10107968" y="1564957"/>
+            <a:ext cx="1815049" cy="461665"/>
+          </a:xfrm>
+          <a:prstGeom prst="rect">
+            <a:avLst/>
+          </a:prstGeom>
+          <a:noFill/>
+        </p:spPr>
+        <p:txBody>
+          <a:bodyPr wrap="none" rtlCol="0">
+            <a:spAutoFit/>
+          </a:bodyPr>
+          <a:lstStyle/>
+          <a:p>
+            <a:r>
+              <a:rPr lang="en-US" sz="2400" dirty="0"/>
+              <a:t>2-pin button</a:t>
+            </a:r>
+          </a:p>
+        </p:txBody>
+      </p:sp>
       <p:cxnSp>
         <p:nvCxnSpPr>
-          <p:cNvPr id="1055" name="Straight Connector 1054">
-            <a:extLst>
-              <a:ext uri="{FF2B5EF4-FFF2-40B4-BE49-F238E27FC236}">
-                <a16:creationId xmlns:a16="http://schemas.microsoft.com/office/drawing/2014/main" id="{DC6E2372-0679-151C-75F1-9B9E069B7764}"/>
+          <p:cNvPr id="1062" name="Straight Connector 1061">
+            <a:extLst>
+              <a:ext uri="{FF2B5EF4-FFF2-40B4-BE49-F238E27FC236}">
+                <a16:creationId xmlns:a16="http://schemas.microsoft.com/office/drawing/2014/main" id="{79298A07-2A07-66D1-2092-98ADE48693D0}"/>
               </a:ext>
             </a:extLst>
           </p:cNvPr>
@@ -3936,19 +4417,16 @@
           <p:nvPr/>
         </p:nvCxnSpPr>
         <p:spPr>
-          <a:xfrm>
-            <a:off x="7358063" y="3487626"/>
-            <a:ext cx="567816" cy="0"/>
+          <a:xfrm flipH="1">
+            <a:off x="7358063" y="1564957"/>
+            <a:ext cx="1059812" cy="1306355"/>
           </a:xfrm>
           <a:prstGeom prst="line">
             <a:avLst/>
           </a:prstGeom>
           <a:ln w="57150">
             <a:solidFill>
-              <a:schemeClr val="tx2">
-                <a:lumMod val="75000"/>
-                <a:lumOff val="25000"/>
-              </a:schemeClr>
+              <a:srgbClr val="0070C0"/>
             </a:solidFill>
           </a:ln>
         </p:spPr>
@@ -3967,264 +4445,6 @@
           </a:fontRef>
         </p:style>
       </p:cxnSp>
-      <p:sp>
-        <p:nvSpPr>
-          <p:cNvPr id="1056" name="Rectangle 1055">
-            <a:extLst>
-              <a:ext uri="{FF2B5EF4-FFF2-40B4-BE49-F238E27FC236}">
-                <a16:creationId xmlns:a16="http://schemas.microsoft.com/office/drawing/2014/main" id="{846C77D8-8DB6-5A49-3CCE-C926E88832E9}"/>
-              </a:ext>
-            </a:extLst>
-          </p:cNvPr>
-          <p:cNvSpPr/>
-          <p:nvPr/>
-        </p:nvSpPr>
-        <p:spPr>
-          <a:xfrm>
-            <a:off x="7358063" y="3161429"/>
-            <a:ext cx="567816" cy="45719"/>
-          </a:xfrm>
-          <a:prstGeom prst="rect">
-            <a:avLst/>
-          </a:prstGeom>
-          <a:solidFill>
-            <a:srgbClr val="04B819"/>
-          </a:solidFill>
-          <a:ln w="3175">
-            <a:solidFill>
-              <a:schemeClr val="tx1"/>
-            </a:solidFill>
-          </a:ln>
-        </p:spPr>
-        <p:style>
-          <a:lnRef idx="2">
-            <a:schemeClr val="accent1">
-              <a:shade val="15000"/>
-            </a:schemeClr>
-          </a:lnRef>
-          <a:fillRef idx="1">
-            <a:schemeClr val="accent1"/>
-          </a:fillRef>
-          <a:effectRef idx="0">
-            <a:schemeClr val="accent1"/>
-          </a:effectRef>
-          <a:fontRef idx="minor">
-            <a:schemeClr val="lt1"/>
-          </a:fontRef>
-        </p:style>
-        <p:txBody>
-          <a:bodyPr rtlCol="0" anchor="ctr"/>
-          <a:lstStyle/>
-          <a:p>
-            <a:pPr algn="ctr"/>
-            <a:endParaRPr lang="en-US"/>
-          </a:p>
-        </p:txBody>
-      </p:sp>
-      <p:sp>
-        <p:nvSpPr>
-          <p:cNvPr id="1059" name="TextBox 1058">
-            <a:extLst>
-              <a:ext uri="{FF2B5EF4-FFF2-40B4-BE49-F238E27FC236}">
-                <a16:creationId xmlns:a16="http://schemas.microsoft.com/office/drawing/2014/main" id="{D5DBC9F1-4655-169C-DB16-ECDD80FBC533}"/>
-              </a:ext>
-            </a:extLst>
-          </p:cNvPr>
-          <p:cNvSpPr txBox="1"/>
-          <p:nvPr/>
-        </p:nvSpPr>
-        <p:spPr>
-          <a:xfrm>
-            <a:off x="9439176" y="1606661"/>
-            <a:ext cx="1348446" cy="461665"/>
-          </a:xfrm>
-          <a:prstGeom prst="rect">
-            <a:avLst/>
-          </a:prstGeom>
-          <a:noFill/>
-        </p:spPr>
-        <p:txBody>
-          <a:bodyPr wrap="none" rtlCol="0">
-            <a:spAutoFit/>
-          </a:bodyPr>
-          <a:lstStyle/>
-          <a:p>
-            <a:r>
-              <a:rPr lang="en-US" sz="2400" dirty="0"/>
-              <a:t>3-pin led</a:t>
-            </a:r>
-          </a:p>
-        </p:txBody>
-      </p:sp>
-      <p:sp>
-        <p:nvSpPr>
-          <p:cNvPr id="1060" name="TextBox 1059">
-            <a:extLst>
-              <a:ext uri="{FF2B5EF4-FFF2-40B4-BE49-F238E27FC236}">
-                <a16:creationId xmlns:a16="http://schemas.microsoft.com/office/drawing/2014/main" id="{B009025B-9DFD-57A8-5307-5FA5436F549B}"/>
-              </a:ext>
-            </a:extLst>
-          </p:cNvPr>
-          <p:cNvSpPr txBox="1"/>
-          <p:nvPr/>
-        </p:nvSpPr>
-        <p:spPr>
-          <a:xfrm>
-            <a:off x="9244868" y="3742673"/>
-            <a:ext cx="1348446" cy="461665"/>
-          </a:xfrm>
-          <a:prstGeom prst="rect">
-            <a:avLst/>
-          </a:prstGeom>
-          <a:noFill/>
-        </p:spPr>
-        <p:txBody>
-          <a:bodyPr wrap="none" rtlCol="0">
-            <a:spAutoFit/>
-          </a:bodyPr>
-          <a:lstStyle/>
-          <a:p>
-            <a:r>
-              <a:rPr lang="en-US" sz="2400" dirty="0"/>
-              <a:t>2-pin led</a:t>
-            </a:r>
-          </a:p>
-        </p:txBody>
-      </p:sp>
-      <p:sp>
-        <p:nvSpPr>
-          <p:cNvPr id="1061" name="TextBox 1060">
-            <a:extLst>
-              <a:ext uri="{FF2B5EF4-FFF2-40B4-BE49-F238E27FC236}">
-                <a16:creationId xmlns:a16="http://schemas.microsoft.com/office/drawing/2014/main" id="{133EEB25-6D34-CAD5-E073-6DE3E4FDA44A}"/>
-              </a:ext>
-            </a:extLst>
-          </p:cNvPr>
-          <p:cNvSpPr txBox="1"/>
-          <p:nvPr/>
-        </p:nvSpPr>
-        <p:spPr>
-          <a:xfrm>
-            <a:off x="410599" y="3813155"/>
-            <a:ext cx="1815049" cy="461665"/>
-          </a:xfrm>
-          <a:prstGeom prst="rect">
-            <a:avLst/>
-          </a:prstGeom>
-          <a:noFill/>
-        </p:spPr>
-        <p:txBody>
-          <a:bodyPr wrap="none" rtlCol="0">
-            <a:spAutoFit/>
-          </a:bodyPr>
-          <a:lstStyle/>
-          <a:p>
-            <a:r>
-              <a:rPr lang="en-US" sz="2400" dirty="0"/>
-              <a:t>2-pin button</a:t>
-            </a:r>
-          </a:p>
-        </p:txBody>
-      </p:sp>
-      <p:cxnSp>
-        <p:nvCxnSpPr>
-          <p:cNvPr id="1062" name="Straight Connector 1061">
-            <a:extLst>
-              <a:ext uri="{FF2B5EF4-FFF2-40B4-BE49-F238E27FC236}">
-                <a16:creationId xmlns:a16="http://schemas.microsoft.com/office/drawing/2014/main" id="{79298A07-2A07-66D1-2092-98ADE48693D0}"/>
-              </a:ext>
-            </a:extLst>
-          </p:cNvPr>
-          <p:cNvCxnSpPr>
-            <a:cxnSpLocks/>
-          </p:cNvCxnSpPr>
-          <p:nvPr/>
-        </p:nvCxnSpPr>
-        <p:spPr>
-          <a:xfrm flipV="1">
-            <a:off x="4003105" y="2950369"/>
-            <a:ext cx="2226245" cy="115293"/>
-          </a:xfrm>
-          <a:prstGeom prst="line">
-            <a:avLst/>
-          </a:prstGeom>
-          <a:ln w="57150">
-            <a:solidFill>
-              <a:schemeClr val="accent2">
-                <a:lumMod val="50000"/>
-              </a:schemeClr>
-            </a:solidFill>
-          </a:ln>
-        </p:spPr>
-        <p:style>
-          <a:lnRef idx="2">
-            <a:schemeClr val="accent1"/>
-          </a:lnRef>
-          <a:fillRef idx="0">
-            <a:schemeClr val="accent1"/>
-          </a:fillRef>
-          <a:effectRef idx="1">
-            <a:schemeClr val="accent1"/>
-          </a:effectRef>
-          <a:fontRef idx="minor">
-            <a:schemeClr val="tx1"/>
-          </a:fontRef>
-        </p:style>
-      </p:cxnSp>
-      <p:sp>
-        <p:nvSpPr>
-          <p:cNvPr id="1066" name="Rectangle 1065">
-            <a:extLst>
-              <a:ext uri="{FF2B5EF4-FFF2-40B4-BE49-F238E27FC236}">
-                <a16:creationId xmlns:a16="http://schemas.microsoft.com/office/drawing/2014/main" id="{0B5CFCCC-7D46-BF9F-97C8-6A39D77AE2BF}"/>
-              </a:ext>
-            </a:extLst>
-          </p:cNvPr>
-          <p:cNvSpPr/>
-          <p:nvPr/>
-        </p:nvSpPr>
-        <p:spPr>
-          <a:xfrm rot="20576136">
-            <a:off x="3992807" y="3260308"/>
-            <a:ext cx="772604" cy="45719"/>
-          </a:xfrm>
-          <a:prstGeom prst="rect">
-            <a:avLst/>
-          </a:prstGeom>
-          <a:solidFill>
-            <a:srgbClr val="FF7621"/>
-          </a:solidFill>
-          <a:ln w="3175">
-            <a:solidFill>
-              <a:schemeClr val="tx1"/>
-            </a:solidFill>
-          </a:ln>
-        </p:spPr>
-        <p:style>
-          <a:lnRef idx="2">
-            <a:schemeClr val="accent1">
-              <a:shade val="15000"/>
-            </a:schemeClr>
-          </a:lnRef>
-          <a:fillRef idx="1">
-            <a:schemeClr val="accent1"/>
-          </a:fillRef>
-          <a:effectRef idx="0">
-            <a:schemeClr val="accent1"/>
-          </a:effectRef>
-          <a:fontRef idx="minor">
-            <a:schemeClr val="lt1"/>
-          </a:fontRef>
-        </p:style>
-        <p:txBody>
-          <a:bodyPr rtlCol="0" anchor="ctr"/>
-          <a:lstStyle/>
-          <a:p>
-            <a:pPr algn="ctr"/>
-            <a:endParaRPr lang="en-US"/>
-          </a:p>
-        </p:txBody>
-      </p:sp>
       <p:grpSp>
         <p:nvGrpSpPr>
           <p:cNvPr id="47" name="Group 46">
@@ -4241,7 +4461,7 @@
         </p:nvGrpSpPr>
         <p:grpSpPr>
           <a:xfrm rot="16200000">
-            <a:off x="272897" y="864787"/>
+            <a:off x="-590230" y="864787"/>
             <a:ext cx="2754481" cy="1025066"/>
             <a:chOff x="842779" y="2150566"/>
             <a:chExt cx="3155892" cy="1174449"/>
@@ -4262,7 +4482,7 @@
             <p:nvPr/>
           </p:nvPicPr>
           <p:blipFill rotWithShape="1">
-            <a:blip r:embed="rId7">
+            <a:blip r:embed="rId8">
               <a:extLst>
                 <a:ext uri="{28A0092B-C50C-407E-A947-70E740481C1C}">
                   <a14:useLocalDpi xmlns:a14="http://schemas.microsoft.com/office/drawing/2010/main" val="0"/>
@@ -4358,107 +4578,101 @@
       </p:grpSp>
       <p:sp>
         <p:nvSpPr>
-          <p:cNvPr id="2" name="Rectangle 1">
-            <a:extLst>
-              <a:ext uri="{FF2B5EF4-FFF2-40B4-BE49-F238E27FC236}">
-                <a16:creationId xmlns:a16="http://schemas.microsoft.com/office/drawing/2014/main" id="{A1DAE4AF-A617-3C76-A499-294B238ABD2F}"/>
-              </a:ext>
-            </a:extLst>
-          </p:cNvPr>
-          <p:cNvSpPr>
-            <a:spLocks noChangeArrowheads="1"/>
-          </p:cNvSpPr>
+          <p:cNvPr id="1037" name="Rectangle 1036">
+            <a:extLst>
+              <a:ext uri="{FF2B5EF4-FFF2-40B4-BE49-F238E27FC236}">
+                <a16:creationId xmlns:a16="http://schemas.microsoft.com/office/drawing/2014/main" id="{6FF4E535-7550-0DC9-2B6C-48BAF2F24329}"/>
+              </a:ext>
+            </a:extLst>
+          </p:cNvPr>
+          <p:cNvSpPr/>
           <p:nvPr/>
         </p:nvSpPr>
-        <p:spPr bwMode="auto">
-          <a:xfrm>
-            <a:off x="0" y="0"/>
-            <a:ext cx="12192000" cy="457200"/>
+        <p:spPr>
+          <a:xfrm flipV="1">
+            <a:off x="4089945" y="2523412"/>
+            <a:ext cx="701527" cy="54557"/>
           </a:xfrm>
           <a:prstGeom prst="rect">
             <a:avLst/>
           </a:prstGeom>
           <a:solidFill>
-            <a:srgbClr val="1E1F22"/>
+            <a:srgbClr val="04B819"/>
           </a:solidFill>
-          <a:ln>
-            <a:noFill/>
+          <a:ln w="3175">
+            <a:solidFill>
+              <a:schemeClr val="tx1"/>
+            </a:solidFill>
           </a:ln>
-          <a:effectLst/>
-          <a:extLst>
-            <a:ext uri="{91240B29-F687-4F45-9708-019B960494DF}">
-              <a14:hiddenLine xmlns:a14="http://schemas.microsoft.com/office/drawing/2010/main" w="9525">
-                <a:solidFill>
-                  <a:schemeClr val="tx1"/>
-                </a:solidFill>
-                <a:miter lim="800000"/>
-                <a:headEnd/>
-                <a:tailEnd/>
-              </a14:hiddenLine>
-            </a:ext>
-            <a:ext uri="{AF507438-7753-43E0-B8FC-AC1667EBCBE1}">
-              <a14:hiddenEffects xmlns:a14="http://schemas.microsoft.com/office/drawing/2010/main">
-                <a:effectLst>
-                  <a:outerShdw dist="35921" dir="2700000" algn="ctr" rotWithShape="0">
-                    <a:schemeClr val="bg2"/>
-                  </a:outerShdw>
-                </a:effectLst>
-              </a14:hiddenEffects>
-            </a:ext>
-          </a:extLst>
         </p:spPr>
-        <p:txBody>
-          <a:bodyPr vert="horz" wrap="none" lIns="91440" tIns="45720" rIns="91440" bIns="45720" numCol="1" anchor="ctr" anchorCtr="0" compatLnSpc="1">
-            <a:prstTxWarp prst="textNoShape">
-              <a:avLst/>
-            </a:prstTxWarp>
-            <a:spAutoFit/>
-          </a:bodyPr>
-          <a:lstStyle/>
-          <a:p>
-            <a:pPr marL="0" marR="0" lvl="0" indent="0" algn="l" defTabSz="914400" rtl="0" eaLnBrk="0" fontAlgn="base" latinLnBrk="0" hangingPunct="0">
-              <a:lnSpc>
-                <a:spcPct val="100000"/>
-              </a:lnSpc>
-              <a:spcBef>
-                <a:spcPct val="0"/>
-              </a:spcBef>
-              <a:spcAft>
-                <a:spcPct val="0"/>
-              </a:spcAft>
-              <a:buClrTx/>
-              <a:buSzTx/>
-              <a:buFontTx/>
-              <a:buNone/>
-              <a:tabLst/>
-            </a:pPr>
-            <a:r>
-              <a:rPr kumimoji="0" lang="en-US" altLang="en-US" sz="1000" b="0" i="0" u="none" strike="noStrike" cap="none" normalizeH="0" baseline="0">
-                <a:ln>
-                  <a:noFill/>
-                </a:ln>
-                <a:solidFill>
-                  <a:srgbClr val="7A7E85"/>
-                </a:solidFill>
-                <a:effectLst/>
-                <a:latin typeface="Arial Unicode MS"/>
-                <a:ea typeface="JetBrains Mono"/>
-              </a:rPr>
-              <a:t>button</a:t>
-            </a:r>
-            <a:endParaRPr kumimoji="0" lang="en-US" altLang="en-US" sz="1800" b="0" i="0" u="none" strike="noStrike" cap="none" normalizeH="0" baseline="0">
-              <a:ln>
-                <a:noFill/>
-              </a:ln>
-              <a:solidFill>
-                <a:schemeClr val="tx1"/>
-              </a:solidFill>
-              <a:effectLst/>
-              <a:latin typeface="Arial" panose="020B0604020202020204" pitchFamily="34" charset="0"/>
-            </a:endParaRPr>
-          </a:p>
-        </p:txBody>
-      </p:sp>
+        <p:style>
+          <a:lnRef idx="2">
+            <a:schemeClr val="accent1">
+              <a:shade val="15000"/>
+            </a:schemeClr>
+          </a:lnRef>
+          <a:fillRef idx="1">
+            <a:schemeClr val="accent1"/>
+          </a:fillRef>
+          <a:effectRef idx="0">
+            <a:schemeClr val="accent1"/>
+          </a:effectRef>
+          <a:fontRef idx="minor">
+            <a:schemeClr val="lt1"/>
+          </a:fontRef>
+        </p:style>
+        <p:txBody>
+          <a:bodyPr rtlCol="0" anchor="ctr"/>
+          <a:lstStyle/>
+          <a:p>
+            <a:pPr algn="ctr"/>
+            <a:endParaRPr lang="en-US"/>
+          </a:p>
+        </p:txBody>
+      </p:sp>
+      <p:cxnSp>
+        <p:nvCxnSpPr>
+          <p:cNvPr id="2" name="Straight Connector 1">
+            <a:extLst>
+              <a:ext uri="{FF2B5EF4-FFF2-40B4-BE49-F238E27FC236}">
+                <a16:creationId xmlns:a16="http://schemas.microsoft.com/office/drawing/2014/main" id="{91E12C83-8704-CBD7-1842-F9A04DB79426}"/>
+              </a:ext>
+            </a:extLst>
+          </p:cNvPr>
+          <p:cNvCxnSpPr>
+            <a:cxnSpLocks/>
+          </p:cNvCxnSpPr>
+          <p:nvPr/>
+        </p:nvCxnSpPr>
+        <p:spPr>
+          <a:xfrm flipH="1">
+            <a:off x="7358063" y="1260898"/>
+            <a:ext cx="1059812" cy="0"/>
+          </a:xfrm>
+          <a:prstGeom prst="line">
+            <a:avLst/>
+          </a:prstGeom>
+          <a:ln w="57150">
+            <a:solidFill>
+              <a:schemeClr val="tx1"/>
+            </a:solidFill>
+          </a:ln>
+        </p:spPr>
+        <p:style>
+          <a:lnRef idx="2">
+            <a:schemeClr val="accent1"/>
+          </a:lnRef>
+          <a:fillRef idx="0">
+            <a:schemeClr val="accent1"/>
+          </a:fillRef>
+          <a:effectRef idx="1">
+            <a:schemeClr val="accent1"/>
+          </a:effectRef>
+          <a:fontRef idx="minor">
+            <a:schemeClr val="tx1"/>
+          </a:fontRef>
+        </p:style>
+      </p:cxnSp>
     </p:spTree>
     <p:extLst>
       <p:ext uri="{BB962C8B-B14F-4D97-AF65-F5344CB8AC3E}">
@@ -4785,4 +4999,319 @@
     </a:ext>
   </a:extLst>
 </a:theme>
+</file>
+
+<file path=ppt/theme/theme2.xml><?xml version="1.0" encoding="utf-8"?>
+<a:theme xmlns:a="http://schemas.openxmlformats.org/drawingml/2006/main" name="Office Theme">
+  <a:themeElements>
+    <a:clrScheme name="Office">
+      <a:dk1>
+        <a:sysClr val="windowText" lastClr="000000"/>
+      </a:dk1>
+      <a:lt1>
+        <a:sysClr val="window" lastClr="FFFFFF"/>
+      </a:lt1>
+      <a:dk2>
+        <a:srgbClr val="0E2841"/>
+      </a:dk2>
+      <a:lt2>
+        <a:srgbClr val="E8E8E8"/>
+      </a:lt2>
+      <a:accent1>
+        <a:srgbClr val="156082"/>
+      </a:accent1>
+      <a:accent2>
+        <a:srgbClr val="E97132"/>
+      </a:accent2>
+      <a:accent3>
+        <a:srgbClr val="196B24"/>
+      </a:accent3>
+      <a:accent4>
+        <a:srgbClr val="0F9ED5"/>
+      </a:accent4>
+      <a:accent5>
+        <a:srgbClr val="A02B93"/>
+      </a:accent5>
+      <a:accent6>
+        <a:srgbClr val="4EA72E"/>
+      </a:accent6>
+      <a:hlink>
+        <a:srgbClr val="467886"/>
+      </a:hlink>
+      <a:folHlink>
+        <a:srgbClr val="96607D"/>
+      </a:folHlink>
+    </a:clrScheme>
+    <a:fontScheme name="Office">
+      <a:majorFont>
+        <a:latin typeface="Aptos Display" panose="02110004020202020204"/>
+        <a:ea typeface=""/>
+        <a:cs typeface=""/>
+        <a:font script="Jpan" typeface="游ゴシック Light"/>
+        <a:font script="Hang" typeface="맑은 고딕"/>
+        <a:font script="Hans" typeface="等线 Light"/>
+        <a:font script="Hant" typeface="新細明體"/>
+        <a:font script="Arab" typeface="Times New Roman"/>
+        <a:font script="Hebr" typeface="Times New Roman"/>
+        <a:font script="Thai" typeface="Angsana New"/>
+        <a:font script="Ethi" typeface="Nyala"/>
+        <a:font script="Beng" typeface="Vrinda"/>
+        <a:font script="Gujr" typeface="Shruti"/>
+        <a:font script="Khmr" typeface="MoolBoran"/>
+        <a:font script="Knda" typeface="Tunga"/>
+        <a:font script="Guru" typeface="Raavi"/>
+        <a:font script="Cans" typeface="Euphemia"/>
+        <a:font script="Cher" typeface="Plantagenet Cherokee"/>
+        <a:font script="Yiii" typeface="Microsoft Yi Baiti"/>
+        <a:font script="Tibt" typeface="Microsoft Himalaya"/>
+        <a:font script="Thaa" typeface="MV Boli"/>
+        <a:font script="Deva" typeface="Mangal"/>
+        <a:font script="Telu" typeface="Gautami"/>
+        <a:font script="Taml" typeface="Latha"/>
+        <a:font script="Syrc" typeface="Estrangelo Edessa"/>
+        <a:font script="Orya" typeface="Kalinga"/>
+        <a:font script="Mlym" typeface="Kartika"/>
+        <a:font script="Laoo" typeface="DokChampa"/>
+        <a:font script="Sinh" typeface="Iskoola Pota"/>
+        <a:font script="Mong" typeface="Mongolian Baiti"/>
+        <a:font script="Viet" typeface="Times New Roman"/>
+        <a:font script="Uigh" typeface="Microsoft Uighur"/>
+        <a:font script="Geor" typeface="Sylfaen"/>
+        <a:font script="Armn" typeface="Arial"/>
+        <a:font script="Bugi" typeface="Leelawadee UI"/>
+        <a:font script="Bopo" typeface="Microsoft JhengHei"/>
+        <a:font script="Java" typeface="Javanese Text"/>
+        <a:font script="Lisu" typeface="Segoe UI"/>
+        <a:font script="Mymr" typeface="Myanmar Text"/>
+        <a:font script="Nkoo" typeface="Ebrima"/>
+        <a:font script="Olck" typeface="Nirmala UI"/>
+        <a:font script="Osma" typeface="Ebrima"/>
+        <a:font script="Phag" typeface="Phagspa"/>
+        <a:font script="Syrn" typeface="Estrangelo Edessa"/>
+        <a:font script="Syrj" typeface="Estrangelo Edessa"/>
+        <a:font script="Syre" typeface="Estrangelo Edessa"/>
+        <a:font script="Sora" typeface="Nirmala UI"/>
+        <a:font script="Tale" typeface="Microsoft Tai Le"/>
+        <a:font script="Talu" typeface="Microsoft New Tai Lue"/>
+        <a:font script="Tfng" typeface="Ebrima"/>
+      </a:majorFont>
+      <a:minorFont>
+        <a:latin typeface="Aptos" panose="02110004020202020204"/>
+        <a:ea typeface=""/>
+        <a:cs typeface=""/>
+        <a:font script="Jpan" typeface="游ゴシック"/>
+        <a:font script="Hang" typeface="맑은 고딕"/>
+        <a:font script="Hans" typeface="等线"/>
+        <a:font script="Hant" typeface="新細明體"/>
+        <a:font script="Arab" typeface="Arial"/>
+        <a:font script="Hebr" typeface="Arial"/>
+        <a:font script="Thai" typeface="Cordia New"/>
+        <a:font script="Ethi" typeface="Nyala"/>
+        <a:font script="Beng" typeface="Vrinda"/>
+        <a:font script="Gujr" typeface="Shruti"/>
+        <a:font script="Khmr" typeface="DaunPenh"/>
+        <a:font script="Knda" typeface="Tunga"/>
+        <a:font script="Guru" typeface="Raavi"/>
+        <a:font script="Cans" typeface="Euphemia"/>
+        <a:font script="Cher" typeface="Plantagenet Cherokee"/>
+        <a:font script="Yiii" typeface="Microsoft Yi Baiti"/>
+        <a:font script="Tibt" typeface="Microsoft Himalaya"/>
+        <a:font script="Thaa" typeface="MV Boli"/>
+        <a:font script="Deva" typeface="Mangal"/>
+        <a:font script="Telu" typeface="Gautami"/>
+        <a:font script="Taml" typeface="Latha"/>
+        <a:font script="Syrc" typeface="Estrangelo Edessa"/>
+        <a:font script="Orya" typeface="Kalinga"/>
+        <a:font script="Mlym" typeface="Kartika"/>
+        <a:font script="Laoo" typeface="DokChampa"/>
+        <a:font script="Sinh" typeface="Iskoola Pota"/>
+        <a:font script="Mong" typeface="Mongolian Baiti"/>
+        <a:font script="Viet" typeface="Arial"/>
+        <a:font script="Uigh" typeface="Microsoft Uighur"/>
+        <a:font script="Geor" typeface="Sylfaen"/>
+        <a:font script="Armn" typeface="Arial"/>
+        <a:font script="Bugi" typeface="Leelawadee UI"/>
+        <a:font script="Bopo" typeface="Microsoft JhengHei"/>
+        <a:font script="Java" typeface="Javanese Text"/>
+        <a:font script="Lisu" typeface="Segoe UI"/>
+        <a:font script="Mymr" typeface="Myanmar Text"/>
+        <a:font script="Nkoo" typeface="Ebrima"/>
+        <a:font script="Olck" typeface="Nirmala UI"/>
+        <a:font script="Osma" typeface="Ebrima"/>
+        <a:font script="Phag" typeface="Phagspa"/>
+        <a:font script="Syrn" typeface="Estrangelo Edessa"/>
+        <a:font script="Syrj" typeface="Estrangelo Edessa"/>
+        <a:font script="Syre" typeface="Estrangelo Edessa"/>
+        <a:font script="Sora" typeface="Nirmala UI"/>
+        <a:font script="Tale" typeface="Microsoft Tai Le"/>
+        <a:font script="Talu" typeface="Microsoft New Tai Lue"/>
+        <a:font script="Tfng" typeface="Ebrima"/>
+      </a:minorFont>
+    </a:fontScheme>
+    <a:fmtScheme name="Office">
+      <a:fillStyleLst>
+        <a:solidFill>
+          <a:schemeClr val="phClr"/>
+        </a:solidFill>
+        <a:gradFill rotWithShape="1">
+          <a:gsLst>
+            <a:gs pos="0">
+              <a:schemeClr val="phClr">
+                <a:lumMod val="110000"/>
+                <a:satMod val="105000"/>
+                <a:tint val="67000"/>
+              </a:schemeClr>
+            </a:gs>
+            <a:gs pos="50000">
+              <a:schemeClr val="phClr">
+                <a:lumMod val="105000"/>
+                <a:satMod val="103000"/>
+                <a:tint val="73000"/>
+              </a:schemeClr>
+            </a:gs>
+            <a:gs pos="100000">
+              <a:schemeClr val="phClr">
+                <a:lumMod val="105000"/>
+                <a:satMod val="109000"/>
+                <a:tint val="81000"/>
+              </a:schemeClr>
+            </a:gs>
+          </a:gsLst>
+          <a:lin ang="5400000" scaled="0"/>
+        </a:gradFill>
+        <a:gradFill rotWithShape="1">
+          <a:gsLst>
+            <a:gs pos="0">
+              <a:schemeClr val="phClr">
+                <a:satMod val="103000"/>
+                <a:lumMod val="102000"/>
+                <a:tint val="94000"/>
+              </a:schemeClr>
+            </a:gs>
+            <a:gs pos="50000">
+              <a:schemeClr val="phClr">
+                <a:satMod val="110000"/>
+                <a:lumMod val="100000"/>
+                <a:shade val="100000"/>
+              </a:schemeClr>
+            </a:gs>
+            <a:gs pos="100000">
+              <a:schemeClr val="phClr">
+                <a:lumMod val="99000"/>
+                <a:satMod val="120000"/>
+                <a:shade val="78000"/>
+              </a:schemeClr>
+            </a:gs>
+          </a:gsLst>
+          <a:lin ang="5400000" scaled="0"/>
+        </a:gradFill>
+      </a:fillStyleLst>
+      <a:lnStyleLst>
+        <a:ln w="12700" cap="flat" cmpd="sng" algn="ctr">
+          <a:solidFill>
+            <a:schemeClr val="phClr"/>
+          </a:solidFill>
+          <a:prstDash val="solid"/>
+          <a:miter lim="800000"/>
+        </a:ln>
+        <a:ln w="19050" cap="flat" cmpd="sng" algn="ctr">
+          <a:solidFill>
+            <a:schemeClr val="phClr"/>
+          </a:solidFill>
+          <a:prstDash val="solid"/>
+          <a:miter lim="800000"/>
+        </a:ln>
+        <a:ln w="25400" cap="flat" cmpd="sng" algn="ctr">
+          <a:solidFill>
+            <a:schemeClr val="phClr"/>
+          </a:solidFill>
+          <a:prstDash val="solid"/>
+          <a:miter lim="800000"/>
+        </a:ln>
+      </a:lnStyleLst>
+      <a:effectStyleLst>
+        <a:effectStyle>
+          <a:effectLst/>
+        </a:effectStyle>
+        <a:effectStyle>
+          <a:effectLst/>
+        </a:effectStyle>
+        <a:effectStyle>
+          <a:effectLst>
+            <a:outerShdw blurRad="57150" dist="19050" dir="5400000" algn="ctr" rotWithShape="0">
+              <a:srgbClr val="000000">
+                <a:alpha val="63000"/>
+              </a:srgbClr>
+            </a:outerShdw>
+          </a:effectLst>
+        </a:effectStyle>
+      </a:effectStyleLst>
+      <a:bgFillStyleLst>
+        <a:solidFill>
+          <a:schemeClr val="phClr"/>
+        </a:solidFill>
+        <a:solidFill>
+          <a:schemeClr val="phClr">
+            <a:tint val="95000"/>
+            <a:satMod val="170000"/>
+          </a:schemeClr>
+        </a:solidFill>
+        <a:gradFill rotWithShape="1">
+          <a:gsLst>
+            <a:gs pos="0">
+              <a:schemeClr val="phClr">
+                <a:tint val="93000"/>
+                <a:satMod val="150000"/>
+                <a:shade val="98000"/>
+                <a:lumMod val="102000"/>
+              </a:schemeClr>
+            </a:gs>
+            <a:gs pos="50000">
+              <a:schemeClr val="phClr">
+                <a:tint val="98000"/>
+                <a:satMod val="130000"/>
+                <a:shade val="90000"/>
+                <a:lumMod val="103000"/>
+              </a:schemeClr>
+            </a:gs>
+            <a:gs pos="100000">
+              <a:schemeClr val="phClr">
+                <a:shade val="63000"/>
+                <a:satMod val="120000"/>
+              </a:schemeClr>
+            </a:gs>
+          </a:gsLst>
+          <a:lin ang="5400000" scaled="0"/>
+        </a:gradFill>
+      </a:bgFillStyleLst>
+    </a:fmtScheme>
+  </a:themeElements>
+  <a:objectDefaults>
+    <a:lnDef>
+      <a:spPr/>
+      <a:bodyPr/>
+      <a:lstStyle/>
+      <a:style>
+        <a:lnRef idx="2">
+          <a:schemeClr val="accent1"/>
+        </a:lnRef>
+        <a:fillRef idx="0">
+          <a:schemeClr val="accent1"/>
+        </a:fillRef>
+        <a:effectRef idx="1">
+          <a:schemeClr val="accent1"/>
+        </a:effectRef>
+        <a:fontRef idx="minor">
+          <a:schemeClr val="tx1"/>
+        </a:fontRef>
+      </a:style>
+    </a:lnDef>
+  </a:objectDefaults>
+  <a:extraClrSchemeLst/>
+  <a:extLst>
+    <a:ext uri="{05A4C25C-085E-4340-85A3-A5531E510DB2}">
+      <thm15:themeFamily xmlns:thm15="http://schemas.microsoft.com/office/thememl/2012/main" name="Office Theme" id="{2E142A2C-CD16-42D6-873A-C26D2A0506FA}" vid="{1BDDFF52-6CD6-40A5-AB3C-68EB2F1E4D0A}"/>
+    </a:ext>
+  </a:extLst>
+</a:theme>
 </file>
</xml_diff>

<commit_message>
added second physical GPIO button (red-black). Short click: next mode. Long click: toggle GUI mode
</commit_message>
<xml_diff>
--- a/sunriseRobot/app_SunriseRobot/info/GPIO_pin_connections.pptx
+++ b/sunriseRobot/app_SunriseRobot/info/GPIO_pin_connections.pptx
@@ -197,7 +197,7 @@
           <a:p>
             <a:fld id="{2FDF1BED-853F-4245-91EE-FADE81ADF85A}" type="datetimeFigureOut">
               <a:rPr lang="en-US" smtClean="0"/>
-              <a:t>5/31/2025</a:t>
+              <a:t>6/2/2025</a:t>
             </a:fld>
             <a:endParaRPr lang="en-US"/>
           </a:p>
@@ -695,7 +695,7 @@
           <a:p>
             <a:fld id="{640B36D2-B36D-4CD7-B01F-B18C9CC58E4D}" type="datetimeFigureOut">
               <a:rPr lang="en-US" smtClean="0"/>
-              <a:t>5/31/2025</a:t>
+              <a:t>6/2/2025</a:t>
             </a:fld>
             <a:endParaRPr lang="en-US"/>
           </a:p>
@@ -893,7 +893,7 @@
           <a:p>
             <a:fld id="{640B36D2-B36D-4CD7-B01F-B18C9CC58E4D}" type="datetimeFigureOut">
               <a:rPr lang="en-US" smtClean="0"/>
-              <a:t>5/31/2025</a:t>
+              <a:t>6/2/2025</a:t>
             </a:fld>
             <a:endParaRPr lang="en-US"/>
           </a:p>
@@ -1101,7 +1101,7 @@
           <a:p>
             <a:fld id="{640B36D2-B36D-4CD7-B01F-B18C9CC58E4D}" type="datetimeFigureOut">
               <a:rPr lang="en-US" smtClean="0"/>
-              <a:t>5/31/2025</a:t>
+              <a:t>6/2/2025</a:t>
             </a:fld>
             <a:endParaRPr lang="en-US"/>
           </a:p>
@@ -1299,7 +1299,7 @@
           <a:p>
             <a:fld id="{640B36D2-B36D-4CD7-B01F-B18C9CC58E4D}" type="datetimeFigureOut">
               <a:rPr lang="en-US" smtClean="0"/>
-              <a:t>5/31/2025</a:t>
+              <a:t>6/2/2025</a:t>
             </a:fld>
             <a:endParaRPr lang="en-US"/>
           </a:p>
@@ -1574,7 +1574,7 @@
           <a:p>
             <a:fld id="{640B36D2-B36D-4CD7-B01F-B18C9CC58E4D}" type="datetimeFigureOut">
               <a:rPr lang="en-US" smtClean="0"/>
-              <a:t>5/31/2025</a:t>
+              <a:t>6/2/2025</a:t>
             </a:fld>
             <a:endParaRPr lang="en-US"/>
           </a:p>
@@ -1839,7 +1839,7 @@
           <a:p>
             <a:fld id="{640B36D2-B36D-4CD7-B01F-B18C9CC58E4D}" type="datetimeFigureOut">
               <a:rPr lang="en-US" smtClean="0"/>
-              <a:t>5/31/2025</a:t>
+              <a:t>6/2/2025</a:t>
             </a:fld>
             <a:endParaRPr lang="en-US"/>
           </a:p>
@@ -2251,7 +2251,7 @@
           <a:p>
             <a:fld id="{640B36D2-B36D-4CD7-B01F-B18C9CC58E4D}" type="datetimeFigureOut">
               <a:rPr lang="en-US" smtClean="0"/>
-              <a:t>5/31/2025</a:t>
+              <a:t>6/2/2025</a:t>
             </a:fld>
             <a:endParaRPr lang="en-US"/>
           </a:p>
@@ -2392,7 +2392,7 @@
           <a:p>
             <a:fld id="{640B36D2-B36D-4CD7-B01F-B18C9CC58E4D}" type="datetimeFigureOut">
               <a:rPr lang="en-US" smtClean="0"/>
-              <a:t>5/31/2025</a:t>
+              <a:t>6/2/2025</a:t>
             </a:fld>
             <a:endParaRPr lang="en-US"/>
           </a:p>
@@ -2505,7 +2505,7 @@
           <a:p>
             <a:fld id="{640B36D2-B36D-4CD7-B01F-B18C9CC58E4D}" type="datetimeFigureOut">
               <a:rPr lang="en-US" smtClean="0"/>
-              <a:t>5/31/2025</a:t>
+              <a:t>6/2/2025</a:t>
             </a:fld>
             <a:endParaRPr lang="en-US"/>
           </a:p>
@@ -2816,7 +2816,7 @@
           <a:p>
             <a:fld id="{640B36D2-B36D-4CD7-B01F-B18C9CC58E4D}" type="datetimeFigureOut">
               <a:rPr lang="en-US" smtClean="0"/>
-              <a:t>5/31/2025</a:t>
+              <a:t>6/2/2025</a:t>
             </a:fld>
             <a:endParaRPr lang="en-US"/>
           </a:p>
@@ -3104,7 +3104,7 @@
           <a:p>
             <a:fld id="{640B36D2-B36D-4CD7-B01F-B18C9CC58E4D}" type="datetimeFigureOut">
               <a:rPr lang="en-US" smtClean="0"/>
-              <a:t>5/31/2025</a:t>
+              <a:t>6/2/2025</a:t>
             </a:fld>
             <a:endParaRPr lang="en-US"/>
           </a:p>
@@ -3345,7 +3345,7 @@
           <a:p>
             <a:fld id="{640B36D2-B36D-4CD7-B01F-B18C9CC58E4D}" type="datetimeFigureOut">
               <a:rPr lang="en-US" smtClean="0"/>
-              <a:t>5/31/2025</a:t>
+              <a:t>6/2/2025</a:t>
             </a:fld>
             <a:endParaRPr lang="en-US"/>
           </a:p>
@@ -4225,7 +4225,7 @@
         </p:blipFill>
         <p:spPr bwMode="auto">
           <a:xfrm rot="5400000">
-            <a:off x="10137322" y="2110976"/>
+            <a:off x="1582982" y="4603112"/>
             <a:ext cx="723553" cy="2636045"/>
           </a:xfrm>
           <a:prstGeom prst="rect">
@@ -4311,7 +4311,48 @@
         </p:nvSpPr>
         <p:spPr>
           <a:xfrm>
-            <a:off x="1510546" y="3134513"/>
+            <a:off x="1441644" y="3113709"/>
+            <a:ext cx="2634183" cy="830997"/>
+          </a:xfrm>
+          <a:prstGeom prst="rect">
+            <a:avLst/>
+          </a:prstGeom>
+          <a:noFill/>
+        </p:spPr>
+        <p:txBody>
+          <a:bodyPr wrap="square" rtlCol="0">
+            <a:spAutoFit/>
+          </a:bodyPr>
+          <a:lstStyle/>
+          <a:p>
+            <a:r>
+              <a:rPr lang="en-US" sz="2400" dirty="0"/>
+              <a:t>3-pin led</a:t>
+            </a:r>
+          </a:p>
+          <a:p>
+            <a:r>
+              <a:rPr lang="en-US" sz="2400" dirty="0"/>
+              <a:t>(green/orange/red)</a:t>
+            </a:r>
+          </a:p>
+        </p:txBody>
+      </p:sp>
+      <p:sp>
+        <p:nvSpPr>
+          <p:cNvPr id="1060" name="TextBox 1059">
+            <a:extLst>
+              <a:ext uri="{FF2B5EF4-FFF2-40B4-BE49-F238E27FC236}">
+                <a16:creationId xmlns:a16="http://schemas.microsoft.com/office/drawing/2014/main" id="{B009025B-9DFD-57A8-5307-5FA5436F549B}"/>
+              </a:ext>
+            </a:extLst>
+          </p:cNvPr>
+          <p:cNvSpPr txBox="1"/>
+          <p:nvPr/>
+        </p:nvSpPr>
+        <p:spPr>
+          <a:xfrm>
+            <a:off x="1570745" y="6282911"/>
             <a:ext cx="1348446" cy="461665"/>
           </a:xfrm>
           <a:prstGeom prst="rect">
@@ -4327,17 +4368,17 @@
           <a:p>
             <a:r>
               <a:rPr lang="en-US" sz="2400" dirty="0"/>
-              <a:t>3-pin led</a:t>
-            </a:r>
-          </a:p>
-        </p:txBody>
-      </p:sp>
-      <p:sp>
-        <p:nvSpPr>
-          <p:cNvPr id="1060" name="TextBox 1059">
-            <a:extLst>
-              <a:ext uri="{FF2B5EF4-FFF2-40B4-BE49-F238E27FC236}">
-                <a16:creationId xmlns:a16="http://schemas.microsoft.com/office/drawing/2014/main" id="{B009025B-9DFD-57A8-5307-5FA5436F549B}"/>
+              <a:t>2-pin led</a:t>
+            </a:r>
+          </a:p>
+        </p:txBody>
+      </p:sp>
+      <p:sp>
+        <p:nvSpPr>
+          <p:cNvPr id="1061" name="TextBox 1060">
+            <a:extLst>
+              <a:ext uri="{FF2B5EF4-FFF2-40B4-BE49-F238E27FC236}">
+                <a16:creationId xmlns:a16="http://schemas.microsoft.com/office/drawing/2014/main" id="{133EEB25-6D34-CAD5-E073-6DE3E4FDA44A}"/>
               </a:ext>
             </a:extLst>
           </p:cNvPr>
@@ -4346,8 +4387,8 @@
         </p:nvSpPr>
         <p:spPr>
           <a:xfrm>
-            <a:off x="10125085" y="3790775"/>
-            <a:ext cx="1348446" cy="461665"/>
+            <a:off x="10146871" y="0"/>
+            <a:ext cx="1815049" cy="830997"/>
           </a:xfrm>
           <a:prstGeom prst="rect">
             <a:avLst/>
@@ -4362,42 +4403,13 @@
           <a:p>
             <a:r>
               <a:rPr lang="en-US" sz="2400" dirty="0"/>
-              <a:t>2-pin led</a:t>
-            </a:r>
-          </a:p>
-        </p:txBody>
-      </p:sp>
-      <p:sp>
-        <p:nvSpPr>
-          <p:cNvPr id="1061" name="TextBox 1060">
-            <a:extLst>
-              <a:ext uri="{FF2B5EF4-FFF2-40B4-BE49-F238E27FC236}">
-                <a16:creationId xmlns:a16="http://schemas.microsoft.com/office/drawing/2014/main" id="{133EEB25-6D34-CAD5-E073-6DE3E4FDA44A}"/>
-              </a:ext>
-            </a:extLst>
-          </p:cNvPr>
-          <p:cNvSpPr txBox="1"/>
-          <p:nvPr/>
-        </p:nvSpPr>
-        <p:spPr>
-          <a:xfrm>
-            <a:off x="10107968" y="1564957"/>
-            <a:ext cx="1815049" cy="461665"/>
-          </a:xfrm>
-          <a:prstGeom prst="rect">
-            <a:avLst/>
-          </a:prstGeom>
-          <a:noFill/>
-        </p:spPr>
-        <p:txBody>
-          <a:bodyPr wrap="none" rtlCol="0">
-            <a:spAutoFit/>
-          </a:bodyPr>
-          <a:lstStyle/>
+              <a:t>2-pin button</a:t>
+            </a:r>
+          </a:p>
           <a:p>
             <a:r>
               <a:rPr lang="en-US" sz="2400" dirty="0"/>
-              <a:t>2-pin button</a:t>
+              <a:t>(blue-black)</a:t>
             </a:r>
           </a:p>
         </p:txBody>
@@ -4655,6 +4667,187 @@
           <a:ln w="57150">
             <a:solidFill>
               <a:schemeClr val="tx1"/>
+            </a:solidFill>
+          </a:ln>
+        </p:spPr>
+        <p:style>
+          <a:lnRef idx="2">
+            <a:schemeClr val="accent1"/>
+          </a:lnRef>
+          <a:fillRef idx="0">
+            <a:schemeClr val="accent1"/>
+          </a:fillRef>
+          <a:effectRef idx="1">
+            <a:schemeClr val="accent1"/>
+          </a:effectRef>
+          <a:fontRef idx="minor">
+            <a:schemeClr val="tx1"/>
+          </a:fontRef>
+        </p:style>
+      </p:cxnSp>
+      <p:pic>
+        <p:nvPicPr>
+          <p:cNvPr id="3" name="Picture 12" descr="China 2 Pin Micro Switch Push Button Factory, Manufacturers and Suppliers -  Kaihua Electronics">
+            <a:extLst>
+              <a:ext uri="{FF2B5EF4-FFF2-40B4-BE49-F238E27FC236}">
+                <a16:creationId xmlns:a16="http://schemas.microsoft.com/office/drawing/2014/main" id="{4207D97B-96B7-D07D-4106-149D4D58C50D}"/>
+              </a:ext>
+            </a:extLst>
+          </p:cNvPr>
+          <p:cNvPicPr>
+            <a:picLocks noChangeAspect="1" noChangeArrowheads="1"/>
+          </p:cNvPicPr>
+          <p:nvPr/>
+        </p:nvPicPr>
+        <p:blipFill rotWithShape="1">
+          <a:blip r:embed="rId6">
+            <a:extLst>
+              <a:ext uri="{BEBA8EAE-BF5A-486C-A8C5-ECC9F3942E4B}">
+                <a14:imgProps xmlns:a14="http://schemas.microsoft.com/office/drawing/2010/main">
+                  <a14:imgLayer r:embed="rId7">
+                    <a14:imgEffect>
+                      <a14:sharpenSoften amount="51000"/>
+                    </a14:imgEffect>
+                  </a14:imgLayer>
+                </a14:imgProps>
+              </a:ext>
+              <a:ext uri="{28A0092B-C50C-407E-A947-70E740481C1C}">
+                <a14:useLocalDpi xmlns:a14="http://schemas.microsoft.com/office/drawing/2010/main" val="0"/>
+              </a:ext>
+            </a:extLst>
+          </a:blip>
+          <a:srcRect l="33600" t="15313" r="34267" b="5673"/>
+          <a:stretch/>
+        </p:blipFill>
+        <p:spPr bwMode="auto">
+          <a:xfrm rot="5400000">
+            <a:off x="8814923" y="1747683"/>
+            <a:ext cx="1591503" cy="2602432"/>
+          </a:xfrm>
+          <a:prstGeom prst="rect">
+            <a:avLst/>
+          </a:prstGeom>
+          <a:noFill/>
+          <a:extLst>
+            <a:ext uri="{909E8E84-426E-40DD-AFC4-6F175D3DCCD1}">
+              <a14:hiddenFill xmlns:a14="http://schemas.microsoft.com/office/drawing/2010/main">
+                <a:solidFill>
+                  <a:srgbClr val="FFFFFF"/>
+                </a:solidFill>
+              </a14:hiddenFill>
+            </a:ext>
+          </a:extLst>
+        </p:spPr>
+      </p:pic>
+      <p:sp>
+        <p:nvSpPr>
+          <p:cNvPr id="4" name="TextBox 3">
+            <a:extLst>
+              <a:ext uri="{FF2B5EF4-FFF2-40B4-BE49-F238E27FC236}">
+                <a16:creationId xmlns:a16="http://schemas.microsoft.com/office/drawing/2014/main" id="{CEF48197-2DB9-F881-7389-C138C262AEC9}"/>
+              </a:ext>
+            </a:extLst>
+          </p:cNvPr>
+          <p:cNvSpPr txBox="1"/>
+          <p:nvPr/>
+        </p:nvSpPr>
+        <p:spPr>
+          <a:xfrm>
+            <a:off x="10347318" y="3191145"/>
+            <a:ext cx="1815049" cy="830997"/>
+          </a:xfrm>
+          <a:prstGeom prst="rect">
+            <a:avLst/>
+          </a:prstGeom>
+          <a:noFill/>
+        </p:spPr>
+        <p:txBody>
+          <a:bodyPr wrap="none" rtlCol="0">
+            <a:spAutoFit/>
+          </a:bodyPr>
+          <a:lstStyle/>
+          <a:p>
+            <a:r>
+              <a:rPr lang="en-US" sz="2400" dirty="0"/>
+              <a:t>2-pin button</a:t>
+            </a:r>
+          </a:p>
+          <a:p>
+            <a:r>
+              <a:rPr lang="en-US" sz="2400" dirty="0"/>
+              <a:t>(red-black)</a:t>
+            </a:r>
+          </a:p>
+        </p:txBody>
+      </p:sp>
+      <p:cxnSp>
+        <p:nvCxnSpPr>
+          <p:cNvPr id="7" name="Straight Connector 6">
+            <a:extLst>
+              <a:ext uri="{FF2B5EF4-FFF2-40B4-BE49-F238E27FC236}">
+                <a16:creationId xmlns:a16="http://schemas.microsoft.com/office/drawing/2014/main" id="{C9442B88-8A44-1FFF-4CB8-16D111471F7C}"/>
+              </a:ext>
+            </a:extLst>
+          </p:cNvPr>
+          <p:cNvCxnSpPr>
+            <a:cxnSpLocks/>
+          </p:cNvCxnSpPr>
+          <p:nvPr/>
+        </p:nvCxnSpPr>
+        <p:spPr>
+          <a:xfrm flipH="1">
+            <a:off x="7358063" y="3489933"/>
+            <a:ext cx="1059812" cy="0"/>
+          </a:xfrm>
+          <a:prstGeom prst="line">
+            <a:avLst/>
+          </a:prstGeom>
+          <a:ln w="57150">
+            <a:solidFill>
+              <a:schemeClr val="tx1"/>
+            </a:solidFill>
+          </a:ln>
+        </p:spPr>
+        <p:style>
+          <a:lnRef idx="2">
+            <a:schemeClr val="accent1"/>
+          </a:lnRef>
+          <a:fillRef idx="0">
+            <a:schemeClr val="accent1"/>
+          </a:fillRef>
+          <a:effectRef idx="1">
+            <a:schemeClr val="accent1"/>
+          </a:effectRef>
+          <a:fontRef idx="minor">
+            <a:schemeClr val="tx1"/>
+          </a:fontRef>
+        </p:style>
+      </p:cxnSp>
+      <p:cxnSp>
+        <p:nvCxnSpPr>
+          <p:cNvPr id="13" name="Straight Connector 12">
+            <a:extLst>
+              <a:ext uri="{FF2B5EF4-FFF2-40B4-BE49-F238E27FC236}">
+                <a16:creationId xmlns:a16="http://schemas.microsoft.com/office/drawing/2014/main" id="{D6BA0234-F6FF-7D0B-A9C0-7891C523C673}"/>
+              </a:ext>
+            </a:extLst>
+          </p:cNvPr>
+          <p:cNvCxnSpPr>
+            <a:cxnSpLocks/>
+          </p:cNvCxnSpPr>
+          <p:nvPr/>
+        </p:nvCxnSpPr>
+        <p:spPr>
+          <a:xfrm flipH="1">
+            <a:off x="7358063" y="3173496"/>
+            <a:ext cx="1059812" cy="0"/>
+          </a:xfrm>
+          <a:prstGeom prst="line">
+            <a:avLst/>
+          </a:prstGeom>
+          <a:ln w="57150">
+            <a:solidFill>
+              <a:srgbClr val="FF0000"/>
             </a:solidFill>
           </a:ln>
         </p:spPr>

</xml_diff>